<commit_message>
Renomme le driver de la chaîne COVID en MainDriverReo
</commit_message>
<xml_diff>
--- a/docs/Presentation_BSY_REO.pptx
+++ b/docs/Presentation_BSY_REO.pptx
@@ -24583,7 +24583,7 @@
                           </a:solidFill>
                           <a:latin typeface="Arial"/>
                         </a:rPr>
-                        <a:t>MainDriverCovidReo, 17 étapes</a:t>
+                        <a:t>MainDriverReo, 17 étapes</a:t>
                       </a:r>
                     </a:p>
                   </a:txBody>
@@ -25925,7 +25925,7 @@
                 </a:solidFill>
                 <a:latin typeface="Courier New"/>
               </a:rPr>
-              <a:t> · MainDriverCovidReo · FetchSourceCovidReo · CovidReoRunner · MainMapperCovid* · ViewsCovidReo</a:t>
+              <a:t> · MainDriverReo · FetchSourceCovidReo · CovidReoRunner · MainMapperCovid* · ViewsCovidReo</a:t>
             </a:r>
           </a:p>
         </p:txBody>

</xml_diff>

<commit_message>
Renomme la configuration de la chaîne COVID en conf/reo_alim.conf
</commit_message>
<xml_diff>
--- a/docs/Presentation_BSY_REO.pptx
+++ b/docs/Presentation_BSY_REO.pptx
@@ -16111,7 +16111,7 @@
                 </a:solidFill>
                 <a:latin typeface="Courier New"/>
               </a:rPr>
-              <a:t>conf/reo_covid.conf</a:t>
+              <a:t>conf/reo_alim.conf</a:t>
             </a:r>
           </a:p>
         </p:txBody>
@@ -17086,7 +17086,7 @@
                 </a:solidFill>
                 <a:latin typeface="Courier New"/>
               </a:rPr>
-              <a:t>bin/run_reo.sh covid prd hdfs:///&lt;chemin&gt;/reo_covid.conf</a:t>
+              <a:t>bin/run_reo.sh covid prd hdfs:///&lt;chemin&gt;/reo_alim.conf</a:t>
             </a:r>
           </a:p>
         </p:txBody>
@@ -24693,7 +24693,7 @@
                           </a:solidFill>
                           <a:latin typeface="Arial"/>
                         </a:rPr>
-                        <a:t>conf/reo_covid.conf</a:t>
+                        <a:t>conf/reo_alim.conf</a:t>
                       </a:r>
                     </a:p>
                   </a:txBody>

</xml_diff>

<commit_message>
Suppression du mot Covid : chaine renommee ALIM dans le code, les fichiers et la documentation
- classes, fichiers et tests : Covid -> Alim (AlimReoRunner, FetchSourceAlimReo, MainMapperAlim*, ViewsAlimReo...)
- bin/run_reo.sh : chaine alim (au lieu de covid)
- conf/reo_alim.conf : cles ALIM_RUBRIQUE, ALIM_DIM_SUPERVISION, ALIM_DIM_CONVERSION
- docs : ANALYSE_TALEND_ALIM_REO.md, presentation regeneree
</commit_message>
<xml_diff>
--- a/docs/Presentation_BSY_REO.pptx
+++ b/docs/Presentation_BSY_REO.pptx
@@ -525,7 +525,7 @@
           <a:lstStyle/>
           <a:p>
             <a:r>
-              <a:t>Présentation du projet BSY_REO : la migration en Scala et Spark des trois chaînes Talend REO : AJUST, MYREO et COVID. Déroulé : le contexte, l’architecture commune, chaque chaîne en détail, la conception transverse, le lancement et l’exploitation, puis les points ouverts.</a:t>
+              <a:t>Présentation du projet BSY_REO : la migration en Scala et Spark des trois chaînes Talend REO : AJUST, MYREO et ALIM. Déroulé : le contexte, l’architecture commune, chaque chaîne en détail, la conception transverse, le lancement et l’exploitation, puis les points ouverts.</a:t>
             </a:r>
           </a:p>
         </p:txBody>
@@ -805,7 +805,7 @@
           <a:lstStyle/>
           <a:p>
             <a:r>
-              <a:t>L’orchestrateur Talend LUD_FLOW_AJUSTEMENT_REO_COVID appelle 19 jobs : 7 jobs Spark et 12 jobs Standard, dont 7 échangent avec SQL Server. Chaque tRunJob lance une JVM. Le bloc MyREO est rejoué pour chaque ligne active du fichier de pilotage reomaker_active.csv, et la table de correspondance NRG vers PCI est recalculée dans chaque conso MyREO. Comme ces répétitions produisent le même contenu, la cible les exécute une seule fois. Côté SQL Server, plusieurs jobs Talend sortaient en succès malgré une erreur, et les tables étaient vidées avant de contrôler les données : la cible contrôle d’abord et s’arrête à la première erreur.</a:t>
+              <a:t>L’orchestrateur Talend d’alimentation REO appelle 19 jobs : 7 jobs Spark et 12 jobs Standard, dont 7 échangent avec SQL Server. Chaque tRunJob lance une JVM. Le bloc MyREO est rejoué pour chaque ligne active du fichier de pilotage reomaker_active.csv, et la table de correspondance NRG vers PCI est recalculée dans chaque conso MyREO. Comme ces répétitions produisent le même contenu, la cible les exécute une seule fois. Côté SQL Server, plusieurs jobs Talend sortaient en succès malgré une erreur, et les tables étaient vidées avant de contrôler les données : la cible contrôle d’abord et s’arrête à la première erreur.</a:t>
             </a:r>
           </a:p>
         </p:txBody>
@@ -1085,7 +1085,7 @@
           <a:lstStyle/>
           <a:p>
             <a:r>
-              <a:t>Les lookups Talend en correspondance unique gardaient une ligne arbitraire en cas de doublon : la cible dédoublonne de façon déterministe, par le plus petit identifiant, avant la jointure. Les lookups sans clé, comme le référentiel des types de MYREO, deviennent un produit cartésien sur les lignes filtrées. Les tSqlRow sont recopiés tels quels. Les routines Java sans équivalent exact en SQL, comme la conversion des montants, sont exposées en UDF Scala. COVID ajoute l’égalité de SG_StringUtils, qui accepte null, et les arrondis ligne par ligne des multiplications Talend. Les requêtes sont dans ViewsAjustReo, ViewsMyReo et ViewsCovidReo. La sémantique a été vérifiée dans le code Java généré par Talend.</a:t>
+              <a:t>Les lookups Talend en correspondance unique gardaient une ligne arbitraire en cas de doublon : la cible dédoublonne de façon déterministe, par le plus petit identifiant, avant la jointure. Les lookups sans clé, comme le référentiel des types de MYREO, deviennent un produit cartésien sur les lignes filtrées. Les tSqlRow sont recopiés tels quels. Les routines Java sans équivalent exact en SQL, comme la conversion des montants, sont exposées en UDF Scala. ALIM ajoute l’égalité de SG_StringUtils, qui accepte null, et les arrondis ligne par ligne des multiplications Talend. Les requêtes sont dans ViewsAjustReo, ViewsMyReo et ViewsAlimReo. La sémantique a été vérifiée dans le code Java généré par Talend.</a:t>
             </a:r>
           </a:p>
         </p:txBody>
@@ -1155,7 +1155,7 @@
           <a:lstStyle/>
           <a:p>
             <a:r>
-              <a:t>Chaque driver lit son propre fichier HOCON, déposé sur HDFS et passé en deuxième argument. Les trois fichiers ont la même structure : les racines par environnement, reprises des contextes Talend, les racines protégées, les paramètres Spark SQL, les interrupteurs d’étapes, puis un bloc par table avec sa racine et son chemin relatif. Une table peut surcharger son chemin pour un environnement donné. Comme des racines et des tables sont déclarées dans plusieurs fichiers, un test vérifie qu’elles restent identiques. Le fichier COVID porte aussi la connexion SQL Server de chaque environnement et l’accès Vault, sur le modèle du projet PUSHSQLSERVER ; le compte et le mot de passe restent dans Vault.</a:t>
+              <a:t>Chaque driver lit son propre fichier HOCON, déposé sur HDFS et passé en deuxième argument. Les trois fichiers ont la même structure : les racines par environnement, reprises des contextes Talend, les racines protégées, les paramètres Spark SQL, les interrupteurs d’étapes, puis un bloc par table avec sa racine et son chemin relatif. Une table peut surcharger son chemin pour un environnement donné. Comme des racines et des tables sont déclarées dans plusieurs fichiers, un test vérifie qu’elles restent identiques. Le fichier ALIM porte aussi la connexion SQL Server de chaque environnement et l’accès Vault, sur le modèle du projet PUSHSQLSERVER ; le compte et le mot de passe restent dans Vault.</a:t>
             </a:r>
           </a:p>
         </p:txBody>
@@ -1225,7 +1225,7 @@
           <a:lstStyle/>
           <a:p>
             <a:r>
-              <a:t>Le build Maven produit le fat jar et un bundle zip qui contient le jar, les trois fichiers de configuration et le script de lancement. Le script prend la chaîne, l’environnement et le chemin HDFS du fichier de configuration de la chaîne. Il choisit la classe du driver et les ressources : AJUST et COVID gardent les ressources de leurs jobs Spark Talend, MYREO tourne avec un petit driver. Pour COVID, le fichier vault.conf de l’AppRole est passé par la variable REO_VAULT_CONF : le script l’envoie au driver YARN. Le script refuse aussi de soumettre si la classe du driver manque dans le jar. Le principal et le keytab Kerberos passent par deux variables d’environnement. Spark 3.3 et Scala 2.12 sont fournis par le cluster.</a:t>
+              <a:t>Le build Maven produit le fat jar et un bundle zip qui contient le jar, les trois fichiers de configuration et le script de lancement. Le script prend la chaîne, l’environnement et le chemin HDFS du fichier de configuration de la chaîne. Il choisit la classe du driver et les ressources : AJUST et ALIM gardent les ressources de leurs jobs Spark Talend, MYREO tourne avec un petit driver. Pour ALIM, le fichier vault.conf de l’AppRole est passé par la variable REO_VAULT_CONF : le script l’envoie au driver YARN. Le script refuse aussi de soumettre si la classe du driver manque dans le jar. Le principal et le keytab Kerberos passent par deux variables d’environnement. Spark 3.3 et Scala 2.12 sont fournis par le cluster.</a:t>
             </a:r>
           </a:p>
         </p:txBody>
@@ -1295,7 +1295,7 @@
           <a:lstStyle/>
           <a:p>
             <a:r>
-              <a:t>Les trois chaînes viennent du projet Talend BSY_A2918. Pour COVID, dont l’export ne contenait que des jars, le code Java a été décompilé. La migration reprend la conception déjà utilisée par le template FDA et par le projet EXP_ENG_FRG_SUV, pour que les équipes retrouvent la même organisation du code. La règle de base est la parité avec Talend : on reproduit d’abord le comportement existant, et chaque écart volontaire est listé dans la documentation du projet.</a:t>
+              <a:t>Les trois chaînes viennent du projet Talend BSY_A2918. Pour ALIM, dont l’export ne contenait que des jars, le code Java a été décompilé. La migration reprend la conception déjà utilisée par le template FDA et par le projet EXP_ENG_FRG_SUV, pour que les équipes retrouvent la même organisation du code. La règle de base est la parité avec Talend : on reproduit d’abord le comportement existant, et chaque écart volontaire est listé dans la documentation du projet.</a:t>
             </a:r>
           </a:p>
         </p:txBody>
@@ -1365,7 +1365,7 @@
           <a:lstStyle/>
           <a:p>
             <a:r>
-              <a:t>Chaque étape a un interrupteur dans le fichier de configuration du driver. Par exemple, en désactivant toutes les étapes AJUST sauf le fait UV, on rejoue seulement le fait UV à partir de la conso enrichie déjà sur disque. Les garde-fous évitent de perdre des données en reprise partielle : le dépôt AJUST n’est supprimé qu’après un run complet, et un fichier MyREO n’est marqué lu que si le SV a été écrit. Côté COVID, les étapes SQL Server peuvent être désactivées : la chaîne relit alors la dernière extraction sur disque, sans se connecter. Aucune chaîne n’écrit dans une racine protégée. Chaque étape écrit une ligne STEP dans les logs, ce qui donne le récapitulatif du run.</a:t>
+              <a:t>Chaque étape a un interrupteur dans le fichier de configuration du driver. Par exemple, en désactivant toutes les étapes AJUST sauf le fait UV, on rejoue seulement le fait UV à partir de la conso enrichie déjà sur disque. Les garde-fous évitent de perdre des données en reprise partielle : le dépôt AJUST n’est supprimé qu’après un run complet, et un fichier MyREO n’est marqué lu que si le SV a été écrit. Côté ALIM, les étapes SQL Server peuvent être désactivées : la chaîne relit alors la dernière extraction sur disque, sans se connecter. Aucune chaîne n’écrit dans une racine protégée. Chaque étape écrit une ligne STEP dans les logs, ce qui donne le récapitulatif du run.</a:t>
             </a:r>
           </a:p>
         </p:txBody>
@@ -1505,7 +1505,7 @@
           <a:lstStyle/>
           <a:p>
             <a:r>
-              <a:t>Ces points viennent de l’analyse du code Talend. Les points de la chaîne COVID sont sur la diapositive suivante. La migration les reproduit à l’identique pour garantir la parité, mais ils ressemblent à des choix à confirmer plutôt qu’à des règles voulues. Côté MYREO, garder seulement le dernier fichier n’a de sens que si chaque extraction est un instantané complet. Le produit cartésien avec tous les types actifs double les montants dès que deux types sont actifs. Les écarts volontaires, eux, sont listés dans le document de conception du projet.</a:t>
+              <a:t>Ces points viennent de l’analyse du code Talend. Les points de la chaîne ALIM sont sur la diapositive suivante. La migration les reproduit à l’identique pour garantir la parité, mais ils ressemblent à des choix à confirmer plutôt qu’à des règles voulues. Côté MYREO, garder seulement le dernier fichier n’a de sens que si chaque extraction est un instantané complet. Le produit cartésien avec tous les types actifs double les montants dès que deux types sont actifs. Les écarts volontaires, eux, sont listés dans le document de conception du projet.</a:t>
             </a:r>
           </a:p>
         </p:txBody>
@@ -1645,7 +1645,7 @@
           <a:lstStyle/>
           <a:p>
             <a:r>
-              <a:t>La recette parallèle fait tourner Talend et Spark sur les mêmes entrées dans un bac à sable HOM, puis compare chaque sortie dans les deux sens avec les requêtes de recette fournies dans le projet. Les points métier de la slide précédente doivent être tranchés avant la bascule. L’équipe CI doit confirmer que le modèle Ansible Tower accepte le déploiement des trois fichiers de configuration. Pour COVID, il faut aussi le fichier vault.conf de l’AppRole, la confirmation des clés du compte BSY_REO dans le secret Vault et, auprès du DBA, le contrat des procédures stockées. La bascule peut se faire chaîne par chaîne, puisque les trois applications sont indépendantes.</a:t>
+              <a:t>La recette parallèle fait tourner Talend et Spark sur les mêmes entrées dans un bac à sable HOM, puis compare chaque sortie dans les deux sens avec les requêtes de recette fournies dans le projet. Les points métier de la slide précédente doivent être tranchés avant la bascule. L’équipe CI doit confirmer que le modèle Ansible Tower accepte le déploiement des trois fichiers de configuration. Pour ALIM, il faut aussi le fichier vault.conf de l’AppRole, la confirmation des clés du compte BSY_REO dans le secret Vault et, auprès du DBA, le contrat des procédures stockées. La bascule peut se faire chaîne par chaîne, puisque les trois applications sont indépendantes.</a:t>
             </a:r>
           </a:p>
         </p:txBody>
@@ -1715,7 +1715,7 @@
           <a:lstStyle/>
           <a:p>
             <a:r>
-              <a:t>Le gain principal est structurel. Côté AJUST, Talend lançait trois applications YARN pour chaque type de données actif, avec des fichiers Parquet relus d’un job à l’autre. Côté MYREO, chaque nouveau fichier lançait une JVM et une connexion Kerberos. Côté COVID, 20 jobs s’appelaient en cascade, et le bloc MyREO était rejoué pour chaque ligne active du fichier de pilotage. Chaque chaîne devient une seule application Spark, découpée en étapes que l’on peut activer ou désactiver.</a:t>
+              <a:t>Le gain principal est structurel. Côté AJUST, Talend lançait trois applications YARN pour chaque type de données actif, avec des fichiers Parquet relus d’un job à l’autre. Côté MYREO, chaque nouveau fichier lançait une JVM et une connexion Kerberos. Côté ALIM, 20 jobs s’appelaient en cascade, et le bloc MyREO était rejoué pour chaque ligne active du fichier de pilotage. Chaque chaîne devient une seule application Spark, découpée en étapes que l’on peut activer ou désactiver.</a:t>
             </a:r>
           </a:p>
         </p:txBody>
@@ -1785,7 +1785,7 @@
           <a:lstStyle/>
           <a:p>
             <a:r>
-              <a:t>AJUST traite les fichiers d’ajustement REO déposés dans le work place : historique en raw, derniers fichiers en SV et BV, conso par type de données, enrichissement GTS, puis fait UV. MYREO détecte les nouvelles extractions de l’outil MyREO déposées en raw et produit un fichier SV. COVID ventile les ajustements saisis dans l’outil REOMAKER et dans SQL Server, les renvoie dans SQL Server et alimente le dépôt lu par AJUST. Les trois chaînes partagent le référentiel des types de données ERK SV.</a:t>
+              <a:t>AJUST traite les fichiers d’ajustement REO déposés dans le work place : historique en raw, derniers fichiers en SV et BV, conso par type de données, enrichissement GTS, puis fait UV. MYREO détecte les nouvelles extractions de l’outil MyREO déposées en raw et produit un fichier SV. ALIM ventile les ajustements saisis dans l’outil REOMAKER et dans SQL Server, les renvoie dans SQL Server et alimente le dépôt lu par AJUST. Les trois chaînes partagent le référentiel des types de données ERK SV.</a:t>
             </a:r>
           </a:p>
         </p:txBody>
@@ -1855,7 +1855,7 @@
           <a:lstStyle/>
           <a:p>
             <a:r>
-              <a:t>Les trois chaînes suivent le découpage du template FDA et d’EXP_ENG_FRG_SUV. Le driver lit la configuration et enchaîne les étapes. Le FetchSource déclare une lecture paresseuse par source, avec un schéma imposé. Le runner fournit ses entrées à chaque mapper. Le mapper enregistre ses vues temporaires et exécute les requêtes Spark SQL de l’objet Views. Le DataWriter écrit les sorties. Chaque couche a sa classe par chaîne : AJUST, MYREO et COVID.</a:t>
+              <a:t>Les trois chaînes suivent le découpage du template FDA et d’EXP_ENG_FRG_SUV. Le driver lit la configuration et enchaîne les étapes. Le FetchSource déclare une lecture paresseuse par source, avec un schéma imposé. Le runner fournit ses entrées à chaque mapper. Le mapper enregistre ses vues temporaires et exécute les requêtes Spark SQL de l’objet Views. Le DataWriter écrit les sorties. Chaque couche a sa classe par chaîne : AJUST, MYREO et ALIM.</a:t>
             </a:r>
           </a:p>
         </p:txBody>
@@ -1925,7 +1925,7 @@
           <a:lstStyle/>
           <a:p>
             <a:r>
-              <a:t>Ces classes sont partagées par les trois drivers. COVID réutilise aussi le plan des types, le filtre d’années et la résolution des 14 clés du fait UV. ReoConf résout chaque chemin à partir de la racine de l’environnement et du chemin relatif de la table. DataWriter centralise les écritures et refuse d’écrire dans un référentiel partagé. StepRunner trace chaque étape et arrête la chaîne à la première erreur, comme le faisaient les tRunJob Talend. Les lecteurs d’Utils reproduisent la lecture Talend : découpe brute sans guillemets, et lecture ligne à ligne pour les jobs Standard. Le référentiel des types de données ERK SV et son schéma sont aussi dans le socle.</a:t>
+              <a:t>Ces classes sont partagées par les trois drivers. ALIM réutilise aussi le plan des types, le filtre d’années et la résolution des 14 clés du fait UV. ReoConf résout chaque chemin à partir de la racine de l’environnement et du chemin relatif de la table. DataWriter centralise les écritures et refuse d’écrire dans un référentiel partagé. StepRunner trace chaque étape et arrête la chaîne à la première erreur, comme le faisaient les tRunJob Talend. Les lecteurs d’Utils reproduisent la lecture Talend : découpe brute sans guillemets, et lecture ligne à ligne pour les jobs Standard. Le référentiel des types de données ERK SV et son schéma sont aussi dans le socle.</a:t>
             </a:r>
           </a:p>
         </p:txBody>
@@ -5351,7 +5351,7 @@
                 </a:solidFill>
                 <a:latin typeface="Arial"/>
               </a:rPr>
-              <a:t>Architecture, conception, logique et lancement des chaînes AJUST, MYREO et COVID</a:t>
+              <a:t>Architecture, conception, logique et lancement des chaînes AJUST, MYREO et ALIM</a:t>
             </a:r>
           </a:p>
         </p:txBody>
@@ -5531,7 +5531,7 @@
         <p:spPr>
           <a:xfrm>
             <a:off x="812800" y="4893310"/>
-            <a:ext cx="3879850" cy="342900"/>
+            <a:ext cx="3803451" cy="342900"/>
           </a:xfrm>
           <a:prstGeom prst="roundRect">
             <a:avLst>
@@ -5577,7 +5577,7 @@
         <p:spPr>
           <a:xfrm>
             <a:off x="965200" y="4969510"/>
-            <a:ext cx="3575050" cy="190500"/>
+            <a:ext cx="3498651" cy="190500"/>
           </a:xfrm>
           <a:prstGeom prst="rect">
             <a:avLst/>
@@ -5600,7 +5600,7 @@
                 </a:solidFill>
                 <a:latin typeface="Arial"/>
               </a:rPr>
-              <a:t>COVID · LUD_FLOW_AJUSTEMENT_REO_COVID</a:t>
+              <a:t>ALIM · orchestrateur Talend d’alimentation REO</a:t>
             </a:r>
           </a:p>
         </p:txBody>
@@ -6345,7 +6345,7 @@
         <p:spPr>
           <a:xfrm>
             <a:off x="812800" y="6261100"/>
-            <a:ext cx="3644503" cy="190500"/>
+            <a:ext cx="3517403" cy="190500"/>
           </a:xfrm>
           <a:prstGeom prst="rect">
             <a:avLst/>
@@ -6368,7 +6368,7 @@
                 </a:solidFill>
                 <a:latin typeface="Arial"/>
               </a:rPr>
-              <a:t>BSY_REO · chaînes REO AJUST, MYREO et COVID</a:t>
+              <a:t>BSY_REO · chaînes REO AJUST, MYREO et ALIM</a:t>
             </a:r>
           </a:p>
         </p:txBody>
@@ -7892,7 +7892,7 @@
         <p:spPr>
           <a:xfrm>
             <a:off x="812800" y="6261100"/>
-            <a:ext cx="3644503" cy="190500"/>
+            <a:ext cx="3517403" cy="190500"/>
           </a:xfrm>
           <a:prstGeom prst="rect">
             <a:avLst/>
@@ -7915,7 +7915,7 @@
                 </a:solidFill>
                 <a:latin typeface="Arial"/>
               </a:rPr>
-              <a:t>BSY_REO · chaînes REO AJUST, MYREO et COVID</a:t>
+              <a:t>BSY_REO · chaînes REO AJUST, MYREO et ALIM</a:t>
             </a:r>
           </a:p>
         </p:txBody>
@@ -8865,7 +8865,7 @@
         <p:spPr>
           <a:xfrm>
             <a:off x="812800" y="6261100"/>
-            <a:ext cx="3644503" cy="190500"/>
+            <a:ext cx="3517403" cy="190500"/>
           </a:xfrm>
           <a:prstGeom prst="rect">
             <a:avLst/>
@@ -8888,7 +8888,7 @@
                 </a:solidFill>
                 <a:latin typeface="Arial"/>
               </a:rPr>
-              <a:t>BSY_REO · chaînes REO AJUST, MYREO et COVID</a:t>
+              <a:t>BSY_REO · chaînes REO AJUST, MYREO et ALIM</a:t>
             </a:r>
           </a:p>
         </p:txBody>
@@ -9068,7 +9068,7 @@
                 </a:solidFill>
                 <a:latin typeface="Arial"/>
               </a:rPr>
-              <a:t>CHAÎNE COVID</a:t>
+              <a:t>CHAÎNE ALIM</a:t>
             </a:r>
           </a:p>
         </p:txBody>
@@ -9105,7 +9105,7 @@
                 </a:solidFill>
                 <a:latin typeface="Arial"/>
               </a:rPr>
-              <a:t>COVID : vingt jobs Talend, une application</a:t>
+              <a:t>ALIM : vingt jobs Talend, une application</a:t>
             </a:r>
           </a:p>
         </p:txBody>
@@ -9836,7 +9836,7 @@
         <p:spPr>
           <a:xfrm>
             <a:off x="812800" y="6261100"/>
-            <a:ext cx="3644503" cy="190500"/>
+            <a:ext cx="3517403" cy="190500"/>
           </a:xfrm>
           <a:prstGeom prst="rect">
             <a:avLst/>
@@ -9859,7 +9859,7 @@
                 </a:solidFill>
                 <a:latin typeface="Arial"/>
               </a:rPr>
-              <a:t>BSY_REO · chaînes REO AJUST, MYREO et COVID</a:t>
+              <a:t>BSY_REO · chaînes REO AJUST, MYREO et ALIM</a:t>
             </a:r>
           </a:p>
         </p:txBody>
@@ -10039,7 +10039,7 @@
                 </a:solidFill>
                 <a:latin typeface="Arial"/>
               </a:rPr>
-              <a:t>CHAÎNE COVID</a:t>
+              <a:t>CHAÎNE ALIM</a:t>
             </a:r>
           </a:p>
         </p:txBody>
@@ -10076,7 +10076,7 @@
                 </a:solidFill>
                 <a:latin typeface="Arial"/>
               </a:rPr>
-              <a:t>COVID : dix-sept étapes en trois blocs</a:t>
+              <a:t>ALIM : dix-sept étapes en trois blocs</a:t>
             </a:r>
           </a:p>
         </p:txBody>
@@ -12422,7 +12422,7 @@
         <p:spPr>
           <a:xfrm>
             <a:off x="812800" y="6261100"/>
-            <a:ext cx="3644503" cy="190500"/>
+            <a:ext cx="3517403" cy="190500"/>
           </a:xfrm>
           <a:prstGeom prst="rect">
             <a:avLst/>
@@ -12445,7 +12445,7 @@
                 </a:solidFill>
                 <a:latin typeface="Arial"/>
               </a:rPr>
-              <a:t>BSY_REO · chaînes REO AJUST, MYREO et COVID</a:t>
+              <a:t>BSY_REO · chaînes REO AJUST, MYREO et ALIM</a:t>
             </a:r>
           </a:p>
         </p:txBody>
@@ -12625,7 +12625,7 @@
                 </a:solidFill>
                 <a:latin typeface="Arial"/>
               </a:rPr>
-              <a:t>CHAÎNE COVID</a:t>
+              <a:t>CHAÎNE ALIM</a:t>
             </a:r>
           </a:p>
         </p:txBody>
@@ -12662,7 +12662,7 @@
                 </a:solidFill>
                 <a:latin typeface="Arial"/>
               </a:rPr>
-              <a:t>COVID : la ventilation des ajustements</a:t>
+              <a:t>ALIM : la ventilation des ajustements</a:t>
             </a:r>
           </a:p>
         </p:txBody>
@@ -13724,7 +13724,7 @@
         <p:spPr>
           <a:xfrm>
             <a:off x="812800" y="6261100"/>
-            <a:ext cx="3644503" cy="190500"/>
+            <a:ext cx="3517403" cy="190500"/>
           </a:xfrm>
           <a:prstGeom prst="rect">
             <a:avLst/>
@@ -13747,7 +13747,7 @@
                 </a:solidFill>
                 <a:latin typeface="Arial"/>
               </a:rPr>
-              <a:t>BSY_REO · chaînes REO AJUST, MYREO et COVID</a:t>
+              <a:t>BSY_REO · chaînes REO AJUST, MYREO et ALIM</a:t>
             </a:r>
           </a:p>
         </p:txBody>
@@ -13927,7 +13927,7 @@
                 </a:solidFill>
                 <a:latin typeface="Arial"/>
               </a:rPr>
-              <a:t>CHAÎNE COVID</a:t>
+              <a:t>CHAÎNE ALIM</a:t>
             </a:r>
           </a:p>
         </p:txBody>
@@ -13964,7 +13964,7 @@
                 </a:solidFill>
                 <a:latin typeface="Arial"/>
               </a:rPr>
-              <a:t>COVID : les échanges avec SQL Server</a:t>
+              <a:t>ALIM : les échanges avec SQL Server</a:t>
             </a:r>
           </a:p>
         </p:txBody>
@@ -14760,7 +14760,7 @@
         <p:spPr>
           <a:xfrm>
             <a:off x="812800" y="6261100"/>
-            <a:ext cx="3644503" cy="190500"/>
+            <a:ext cx="3517403" cy="190500"/>
           </a:xfrm>
           <a:prstGeom prst="rect">
             <a:avLst/>
@@ -14783,7 +14783,7 @@
                 </a:solidFill>
                 <a:latin typeface="Arial"/>
               </a:rPr>
-              <a:t>BSY_REO · chaînes REO AJUST, MYREO et COVID</a:t>
+              <a:t>BSY_REO · chaînes REO AJUST, MYREO et ALIM</a:t>
             </a:r>
           </a:p>
         </p:txBody>
@@ -15518,7 +15518,7 @@
                           </a:solidFill>
                           <a:latin typeface="Arial"/>
                         </a:rPr>
-                        <a:t>UDF covid_mul64 et covid_mul32</a:t>
+                        <a:t>UDF alim_mul64 et alim_mul32</a:t>
                       </a:r>
                     </a:p>
                   </a:txBody>
@@ -15542,7 +15542,7 @@
         <p:spPr>
           <a:xfrm>
             <a:off x="812800" y="6261100"/>
-            <a:ext cx="3644503" cy="190500"/>
+            <a:ext cx="3517403" cy="190500"/>
           </a:xfrm>
           <a:prstGeom prst="rect">
             <a:avLst/>
@@ -15565,7 +15565,7 @@
                 </a:solidFill>
                 <a:latin typeface="Arial"/>
               </a:rPr>
-              <a:t>BSY_REO · chaînes REO AJUST, MYREO et COVID</a:t>
+              <a:t>BSY_REO · chaînes REO AJUST, MYREO et ALIM</a:t>
             </a:r>
           </a:p>
         </p:txBody>
@@ -16615,7 +16615,7 @@
         <p:spPr>
           <a:xfrm>
             <a:off x="812800" y="6261100"/>
-            <a:ext cx="3644503" cy="190500"/>
+            <a:ext cx="3517403" cy="190500"/>
           </a:xfrm>
           <a:prstGeom prst="rect">
             <a:avLst/>
@@ -16638,7 +16638,7 @@
                 </a:solidFill>
                 <a:latin typeface="Arial"/>
               </a:rPr>
-              <a:t>BSY_REO · chaînes REO AJUST, MYREO et COVID</a:t>
+              <a:t>BSY_REO · chaînes REO AJUST, MYREO et ALIM</a:t>
             </a:r>
           </a:p>
         </p:txBody>
@@ -17086,7 +17086,7 @@
                 </a:solidFill>
                 <a:latin typeface="Courier New"/>
               </a:rPr>
-              <a:t>bin/run_reo.sh covid prd hdfs:///&lt;chemin&gt;/reo_alim.conf</a:t>
+              <a:t>bin/run_reo.sh alim prd hdfs:///&lt;chemin&gt;/reo_alim.conf</a:t>
             </a:r>
           </a:p>
         </p:txBody>
@@ -17208,7 +17208,7 @@
                 </a:solidFill>
                 <a:latin typeface="Arial"/>
               </a:rPr>
-              <a:t>Chaîne ajust, myreo ou covid, environnement dev, int, hom, prd ou rec. Les arguments en plus vont à spark3-submit.</a:t>
+              <a:t>Chaîne ajust, myreo ou alim, environnement dev, int, hom, prd ou rec. Les arguments en plus vont à spark3-submit.</a:t>
             </a:r>
           </a:p>
         </p:txBody>
@@ -17330,7 +17330,7 @@
                 </a:solidFill>
                 <a:latin typeface="Arial"/>
               </a:rPr>
-              <a:t>AJUST et COVID : driver 16 Go et 4 cœurs. MYREO : driver 2 Go, exécuteurs 2 Go. YARN en mode cluster.</a:t>
+              <a:t>AJUST et ALIM : driver 16 Go et 4 cœurs. MYREO : driver 2 Go, exécuteurs 2 Go. YARN en mode cluster.</a:t>
             </a:r>
           </a:p>
         </p:txBody>
@@ -17466,7 +17466,7 @@
         <p:spPr>
           <a:xfrm>
             <a:off x="812800" y="6261100"/>
-            <a:ext cx="3644503" cy="190500"/>
+            <a:ext cx="3517403" cy="190500"/>
           </a:xfrm>
           <a:prstGeom prst="rect">
             <a:avLst/>
@@ -17489,7 +17489,7 @@
                 </a:solidFill>
                 <a:latin typeface="Arial"/>
               </a:rPr>
-              <a:t>BSY_REO · chaînes REO AJUST, MYREO et COVID</a:t>
+              <a:t>BSY_REO · chaînes REO AJUST, MYREO et ALIM</a:t>
             </a:r>
           </a:p>
         </p:txBody>
@@ -17828,7 +17828,7 @@
                 </a:solidFill>
                 <a:latin typeface="Arial"/>
               </a:rPr>
-              <a:t>Trois chaînes Talend du projet BSY_A2918 : 6 jobs pour AJUST, 2 pour MYREO, 20 pour COVID.</a:t>
+              <a:t>Trois chaînes Talend du projet BSY_A2918 : 6 jobs pour AJUST, 2 pour MYREO, 20 pour ALIM.</a:t>
             </a:r>
           </a:p>
         </p:txBody>
@@ -18123,7 +18123,7 @@
         <p:spPr>
           <a:xfrm>
             <a:off x="812800" y="6261100"/>
-            <a:ext cx="3644503" cy="190500"/>
+            <a:ext cx="3517403" cy="190500"/>
           </a:xfrm>
           <a:prstGeom prst="rect">
             <a:avLst/>
@@ -18146,7 +18146,7 @@
                 </a:solidFill>
                 <a:latin typeface="Arial"/>
               </a:rPr>
-              <a:t>BSY_REO · chaînes REO AJUST, MYREO et COVID</a:t>
+              <a:t>BSY_REO · chaînes REO AJUST, MYREO et ALIM</a:t>
             </a:r>
           </a:p>
         </p:txBody>
@@ -18644,7 +18644,7 @@
                 </a:solidFill>
                 <a:latin typeface="Arial"/>
               </a:rPr>
-              <a:t>AJUST ne supprime le dépôt qu’après un run complet. MYREO ne marque un fichier lu que si le SV est écrit. COVID contrôle les données avant tout vidage SQL Server.</a:t>
+              <a:t>AJUST ne supprime le dépôt qu’après un run complet. MYREO ne marque un fichier lu que si le SV est écrit. ALIM contrôle les données avant tout vidage SQL Server.</a:t>
             </a:r>
           </a:p>
         </p:txBody>
@@ -18817,7 +18817,7 @@
         <p:spPr>
           <a:xfrm>
             <a:off x="812800" y="6261100"/>
-            <a:ext cx="3644503" cy="190500"/>
+            <a:ext cx="3517403" cy="190500"/>
           </a:xfrm>
           <a:prstGeom prst="rect">
             <a:avLst/>
@@ -18840,7 +18840,7 @@
                 </a:solidFill>
                 <a:latin typeface="Arial"/>
               </a:rPr>
-              <a:t>BSY_REO · chaînes REO AJUST, MYREO et COVID</a:t>
+              <a:t>BSY_REO · chaînes REO AJUST, MYREO et ALIM</a:t>
             </a:r>
           </a:p>
         </p:txBody>
@@ -19301,7 +19301,7 @@
                 </a:solidFill>
                 <a:latin typeface="Arial"/>
               </a:rPr>
-              <a:t>scénarios de bout en bout : 3 AJUST, 5 MYREO, 4 COVID</a:t>
+              <a:t>scénarios de bout en bout : 3 AJUST, 5 MYREO, 4 ALIM</a:t>
             </a:r>
           </a:p>
         </p:txBody>
@@ -20220,7 +20220,7 @@
         <p:spPr>
           <a:xfrm>
             <a:off x="812800" y="6261100"/>
-            <a:ext cx="3644503" cy="190500"/>
+            <a:ext cx="3517403" cy="190500"/>
           </a:xfrm>
           <a:prstGeom prst="rect">
             <a:avLst/>
@@ -20243,7 +20243,7 @@
                 </a:solidFill>
                 <a:latin typeface="Arial"/>
               </a:rPr>
-              <a:t>BSY_REO · chaînes REO AJUST, MYREO et COVID</a:t>
+              <a:t>BSY_REO · chaînes REO AJUST, MYREO et ALIM</a:t>
             </a:r>
           </a:p>
         </p:txBody>
@@ -21036,7 +21036,7 @@
         <p:spPr>
           <a:xfrm>
             <a:off x="812800" y="6261100"/>
-            <a:ext cx="3644503" cy="190500"/>
+            <a:ext cx="3517403" cy="190500"/>
           </a:xfrm>
           <a:prstGeom prst="rect">
             <a:avLst/>
@@ -21059,7 +21059,7 @@
                 </a:solidFill>
                 <a:latin typeface="Arial"/>
               </a:rPr>
-              <a:t>BSY_REO · chaînes REO AJUST, MYREO et COVID</a:t>
+              <a:t>BSY_REO · chaînes REO AJUST, MYREO et ALIM</a:t>
             </a:r>
           </a:p>
         </p:txBody>
@@ -21239,7 +21239,7 @@
                 </a:solidFill>
                 <a:latin typeface="Arial"/>
               </a:rPr>
-              <a:t>POINTS OUVERTS · COVID</a:t>
+              <a:t>POINTS OUVERTS · ALIM</a:t>
             </a:r>
           </a:p>
         </p:txBody>
@@ -21276,7 +21276,7 @@
                 </a:solidFill>
                 <a:latin typeface="Arial"/>
               </a:rPr>
-              <a:t>Points COVID à faire valider</a:t>
+              <a:t>Points ALIM à faire valider</a:t>
             </a:r>
           </a:p>
         </p:txBody>
@@ -22602,7 +22602,7 @@
         <p:spPr>
           <a:xfrm>
             <a:off x="812800" y="6261100"/>
-            <a:ext cx="3644503" cy="190500"/>
+            <a:ext cx="3517403" cy="190500"/>
           </a:xfrm>
           <a:prstGeom prst="rect">
             <a:avLst/>
@@ -22625,7 +22625,7 @@
                 </a:solidFill>
                 <a:latin typeface="Arial"/>
               </a:rPr>
-              <a:t>BSY_REO · chaînes REO AJUST, MYREO et COVID</a:t>
+              <a:t>BSY_REO · chaînes REO AJUST, MYREO et ALIM</a:t>
             </a:r>
           </a:p>
         </p:txBody>
@@ -23101,7 +23101,7 @@
                 </a:solidFill>
                 <a:latin typeface="Arial"/>
               </a:rPr>
-              <a:t>COVID : vault.conf de l’AppRole déposé, clés du secret Vault confirmées, contrat des procédures obtenu</a:t>
+              <a:t>ALIM : vault.conf de l’AppRole déposé, clés du secret Vault confirmées, contrat des procédures obtenu</a:t>
             </a:r>
           </a:p>
         </p:txBody>
@@ -23651,7 +23651,7 @@
                 </a:solidFill>
                 <a:latin typeface="Arial"/>
               </a:rPr>
-              <a:t>COVID</a:t>
+              <a:t>ALIM</a:t>
             </a:r>
           </a:p>
         </p:txBody>
@@ -23985,7 +23985,7 @@
                           </a:solidFill>
                           <a:latin typeface="Arial"/>
                         </a:rPr>
-                        <a:t>COVID</a:t>
+                        <a:t>ALIM</a:t>
                       </a:r>
                     </a:p>
                   </a:txBody>
@@ -24127,7 +24127,7 @@
                           </a:solidFill>
                           <a:latin typeface="Arial"/>
                         </a:rPr>
-                        <a:t>LUD_FLOW_AJUSTEMENT_</a:t>
+                        <a:t>Orchestrateur</a:t>
                       </a:r>
                     </a:p>
                     <a:p>
@@ -24143,7 +24143,7 @@
                           </a:solidFill>
                           <a:latin typeface="Arial"/>
                         </a:rPr>
-                        <a:t>REO_COVID</a:t>
+                        <a:t>d’alimentation REO</a:t>
                       </a:r>
                     </a:p>
                   </a:txBody>
@@ -24717,7 +24717,7 @@
         <p:spPr>
           <a:xfrm>
             <a:off x="812800" y="6261100"/>
-            <a:ext cx="3644503" cy="190500"/>
+            <a:ext cx="3517403" cy="190500"/>
           </a:xfrm>
           <a:prstGeom prst="rect">
             <a:avLst/>
@@ -24740,7 +24740,7 @@
                 </a:solidFill>
                 <a:latin typeface="Arial"/>
               </a:rPr>
-              <a:t>BSY_REO · chaînes REO AJUST, MYREO et COVID</a:t>
+              <a:t>BSY_REO · chaînes REO AJUST, MYREO et ALIM</a:t>
             </a:r>
           </a:p>
         </p:txBody>
@@ -25916,7 +25916,7 @@
                 </a:solidFill>
                 <a:latin typeface="Courier New"/>
               </a:rPr>
-              <a:t>COVID</a:t>
+              <a:t>ALIM</a:t>
             </a:r>
             <a:r>
               <a:rPr sz="1200" b="0">
@@ -25925,7 +25925,7 @@
                 </a:solidFill>
                 <a:latin typeface="Courier New"/>
               </a:rPr>
-              <a:t> · MainDriverReo · FetchSourceCovidReo · CovidReoRunner · MainMapperCovid* · ViewsCovidReo</a:t>
+              <a:t> · MainDriverReo · FetchSourceAlimReo · AlimReoRunner · MainMapperAlim* · ViewsAlimReo</a:t>
             </a:r>
           </a:p>
         </p:txBody>
@@ -25976,7 +25976,7 @@
         <p:spPr>
           <a:xfrm>
             <a:off x="812800" y="6261100"/>
-            <a:ext cx="3644503" cy="190500"/>
+            <a:ext cx="3517403" cy="190500"/>
           </a:xfrm>
           <a:prstGeom prst="rect">
             <a:avLst/>
@@ -25999,7 +25999,7 @@
                 </a:solidFill>
                 <a:latin typeface="Arial"/>
               </a:rPr>
-              <a:t>BSY_REO · chaînes REO AJUST, MYREO et COVID</a:t>
+              <a:t>BSY_REO · chaînes REO AJUST, MYREO et ALIM</a:t>
             </a:r>
           </a:p>
         </p:txBody>
@@ -26962,7 +26962,7 @@
         <p:spPr>
           <a:xfrm>
             <a:off x="812800" y="6261100"/>
-            <a:ext cx="3644503" cy="190500"/>
+            <a:ext cx="3517403" cy="190500"/>
           </a:xfrm>
           <a:prstGeom prst="rect">
             <a:avLst/>
@@ -26985,7 +26985,7 @@
                 </a:solidFill>
                 <a:latin typeface="Arial"/>
               </a:rPr>
-              <a:t>BSY_REO · chaînes REO AJUST, MYREO et COVID</a:t>
+              <a:t>BSY_REO · chaînes REO AJUST, MYREO et ALIM</a:t>
             </a:r>
           </a:p>
         </p:txBody>
@@ -27850,7 +27850,7 @@
         <p:spPr>
           <a:xfrm>
             <a:off x="812800" y="6261100"/>
-            <a:ext cx="3644503" cy="190500"/>
+            <a:ext cx="3517403" cy="190500"/>
           </a:xfrm>
           <a:prstGeom prst="rect">
             <a:avLst/>
@@ -27873,7 +27873,7 @@
                 </a:solidFill>
                 <a:latin typeface="Arial"/>
               </a:rPr>
-              <a:t>BSY_REO · chaînes REO AJUST, MYREO et COVID</a:t>
+              <a:t>BSY_REO · chaînes REO AJUST, MYREO et ALIM</a:t>
             </a:r>
           </a:p>
         </p:txBody>
@@ -29875,7 +29875,7 @@
         <p:spPr>
           <a:xfrm>
             <a:off x="812800" y="6261100"/>
-            <a:ext cx="3644503" cy="190500"/>
+            <a:ext cx="3517403" cy="190500"/>
           </a:xfrm>
           <a:prstGeom prst="rect">
             <a:avLst/>
@@ -29898,7 +29898,7 @@
                 </a:solidFill>
                 <a:latin typeface="Arial"/>
               </a:rPr>
-              <a:t>BSY_REO · chaînes REO AJUST, MYREO et COVID</a:t>
+              <a:t>BSY_REO · chaînes REO AJUST, MYREO et ALIM</a:t>
             </a:r>
           </a:p>
         </p:txBody>
@@ -31197,7 +31197,7 @@
         <p:spPr>
           <a:xfrm>
             <a:off x="812800" y="6261100"/>
-            <a:ext cx="3644503" cy="190500"/>
+            <a:ext cx="3517403" cy="190500"/>
           </a:xfrm>
           <a:prstGeom prst="rect">
             <a:avLst/>
@@ -31220,7 +31220,7 @@
                 </a:solidFill>
                 <a:latin typeface="Arial"/>
               </a:rPr>
-              <a:t>BSY_REO · chaînes REO AJUST, MYREO et COVID</a:t>
+              <a:t>BSY_REO · chaînes REO AJUST, MYREO et ALIM</a:t>
             </a:r>
           </a:p>
         </p:txBody>

</xml_diff>